<commit_message>
docs: add 'Hecho con IA' section + credit AI tools in slides
README gains a Hecho con IA section (Stitch for design, Claude for TDD/dev) and the methodology slide now credits the AI toolchain.

Co-Authored-By: Claude Opus 4.8 <noreply@anthropic.com>
</commit_message>
<xml_diff>
--- a/docs/slides/Slotify-TFM.pptx
+++ b/docs/slides/Slotify-TFM.pptx
@@ -12933,7 +12933,7 @@
         <p:spPr>
           <a:xfrm>
             <a:off x="640080" y="1645920"/>
-            <a:ext cx="10058400" cy="457200"/>
+            <a:ext cx="10058400" cy="411480"/>
           </a:xfrm>
           <a:prstGeom prst="rect">
             <a:avLst/>
@@ -12965,7 +12965,60 @@
       </p:sp>
       <p:sp>
         <p:nvSpPr>
-          <p:cNvPr id="6" name="Shape 4"/>
+          <p:cNvPr id="6" name="Text 4"/>
+          <p:cNvSpPr/>
+          <p:nvPr/>
+        </p:nvSpPr>
+        <p:spPr>
+          <a:xfrm>
+            <a:off x="640080" y="2084832"/>
+            <a:ext cx="10058400" cy="320040"/>
+          </a:xfrm>
+          <a:prstGeom prst="rect">
+            <a:avLst/>
+          </a:prstGeom>
+          <a:noFill/>
+          <a:ln/>
+        </p:spPr>
+        <p:txBody>
+          <a:bodyPr wrap="square" lIns="0" tIns="0" rIns="0" bIns="0" rtlCol="0" anchor="ctr"/>
+          <a:lstStyle/>
+          <a:p>
+            <a:pPr indent="0" marL="0">
+              <a:buNone/>
+            </a:pPr>
+            <a:r>
+              <a:rPr lang="en-US" sz="1250" b="1" dirty="0">
+                <a:solidFill>
+                  <a:srgbClr val="06B6D4"/>
+                </a:solidFill>
+                <a:latin typeface="Calibri" pitchFamily="34" charset="0"/>
+                <a:ea typeface="Calibri" pitchFamily="34" charset="-122"/>
+                <a:cs typeface="Calibri" pitchFamily="34" charset="-120"/>
+              </a:rPr>
+              <a:t>Herramientas IA:  </a:t>
+            </a:r>
+            <a:pPr indent="0" marL="0">
+              <a:buNone/>
+            </a:pPr>
+            <a:r>
+              <a:rPr lang="en-US" sz="1250" dirty="0">
+                <a:solidFill>
+                  <a:srgbClr val="C9BEF2"/>
+                </a:solidFill>
+                <a:latin typeface="Calibri" pitchFamily="34" charset="0"/>
+                <a:ea typeface="Calibri" pitchFamily="34" charset="-122"/>
+                <a:cs typeface="Calibri" pitchFamily="34" charset="-120"/>
+              </a:rPr>
+              <a:t>Google Stitch (diseño de UI)  ·  Claude (desarrollo + TDD)</a:t>
+            </a:r>
+            <a:endParaRPr lang="en-US" sz="1250" dirty="0"/>
+          </a:p>
+        </p:txBody>
+      </p:sp>
+      <p:sp>
+        <p:nvSpPr>
+          <p:cNvPr id="7" name="Shape 5"/>
           <p:cNvSpPr/>
           <p:nvPr/>
         </p:nvSpPr>
@@ -12999,7 +13052,7 @@
       </p:sp>
       <p:sp>
         <p:nvSpPr>
-          <p:cNvPr id="7" name="Shape 5"/>
+          <p:cNvPr id="8" name="Shape 6"/>
           <p:cNvSpPr/>
           <p:nvPr/>
         </p:nvSpPr>
@@ -13026,7 +13079,7 @@
       </p:sp>
       <p:pic>
         <p:nvPicPr>
-          <p:cNvPr id="8" name="Image 0" descr="preencoded.png">    </p:cNvPr>
+          <p:cNvPr id="9" name="Image 0" descr="preencoded.png">    </p:cNvPr>
           <p:cNvPicPr>
             <a:picLocks noChangeAspect="1"/>
           </p:cNvPicPr>
@@ -13050,7 +13103,7 @@
       </p:pic>
       <p:sp>
         <p:nvSpPr>
-          <p:cNvPr id="9" name="Text 6"/>
+          <p:cNvPr id="10" name="Text 7"/>
           <p:cNvSpPr/>
           <p:nvPr/>
         </p:nvSpPr>
@@ -13089,7 +13142,7 @@
       </p:sp>
       <p:sp>
         <p:nvSpPr>
-          <p:cNvPr id="10" name="Text 7"/>
+          <p:cNvPr id="11" name="Text 8"/>
           <p:cNvSpPr/>
           <p:nvPr/>
         </p:nvSpPr>
@@ -13131,7 +13184,7 @@
       </p:sp>
       <p:sp>
         <p:nvSpPr>
-          <p:cNvPr id="11" name="Text 8"/>
+          <p:cNvPr id="12" name="Text 9"/>
           <p:cNvSpPr/>
           <p:nvPr/>
         </p:nvSpPr>
@@ -13170,7 +13223,7 @@
       </p:sp>
       <p:sp>
         <p:nvSpPr>
-          <p:cNvPr id="12" name="Shape 9"/>
+          <p:cNvPr id="13" name="Shape 10"/>
           <p:cNvSpPr/>
           <p:nvPr/>
         </p:nvSpPr>
@@ -13204,7 +13257,7 @@
       </p:sp>
       <p:sp>
         <p:nvSpPr>
-          <p:cNvPr id="13" name="Shape 10"/>
+          <p:cNvPr id="14" name="Shape 11"/>
           <p:cNvSpPr/>
           <p:nvPr/>
         </p:nvSpPr>
@@ -13231,7 +13284,7 @@
       </p:sp>
       <p:pic>
         <p:nvPicPr>
-          <p:cNvPr id="14" name="Image 1" descr="preencoded.png">    </p:cNvPr>
+          <p:cNvPr id="15" name="Image 1" descr="preencoded.png">    </p:cNvPr>
           <p:cNvPicPr>
             <a:picLocks noChangeAspect="1"/>
           </p:cNvPicPr>
@@ -13255,7 +13308,7 @@
       </p:pic>
       <p:sp>
         <p:nvSpPr>
-          <p:cNvPr id="15" name="Text 11"/>
+          <p:cNvPr id="16" name="Text 12"/>
           <p:cNvSpPr/>
           <p:nvPr/>
         </p:nvSpPr>
@@ -13294,7 +13347,7 @@
       </p:sp>
       <p:sp>
         <p:nvSpPr>
-          <p:cNvPr id="16" name="Text 12"/>
+          <p:cNvPr id="17" name="Text 13"/>
           <p:cNvSpPr/>
           <p:nvPr/>
         </p:nvSpPr>
@@ -13336,7 +13389,7 @@
       </p:sp>
       <p:sp>
         <p:nvSpPr>
-          <p:cNvPr id="17" name="Text 13"/>
+          <p:cNvPr id="18" name="Text 14"/>
           <p:cNvSpPr/>
           <p:nvPr/>
         </p:nvSpPr>
@@ -13375,7 +13428,7 @@
       </p:sp>
       <p:sp>
         <p:nvSpPr>
-          <p:cNvPr id="18" name="Shape 14"/>
+          <p:cNvPr id="19" name="Shape 15"/>
           <p:cNvSpPr/>
           <p:nvPr/>
         </p:nvSpPr>
@@ -13409,7 +13462,7 @@
       </p:sp>
       <p:sp>
         <p:nvSpPr>
-          <p:cNvPr id="19" name="Shape 15"/>
+          <p:cNvPr id="20" name="Shape 16"/>
           <p:cNvSpPr/>
           <p:nvPr/>
         </p:nvSpPr>
@@ -13436,7 +13489,7 @@
       </p:sp>
       <p:pic>
         <p:nvPicPr>
-          <p:cNvPr id="20" name="Image 2" descr="preencoded.png">    </p:cNvPr>
+          <p:cNvPr id="21" name="Image 2" descr="preencoded.png">    </p:cNvPr>
           <p:cNvPicPr>
             <a:picLocks noChangeAspect="1"/>
           </p:cNvPicPr>
@@ -13460,7 +13513,7 @@
       </p:pic>
       <p:sp>
         <p:nvSpPr>
-          <p:cNvPr id="21" name="Text 16"/>
+          <p:cNvPr id="22" name="Text 17"/>
           <p:cNvSpPr/>
           <p:nvPr/>
         </p:nvSpPr>
@@ -13499,7 +13552,7 @@
       </p:sp>
       <p:sp>
         <p:nvSpPr>
-          <p:cNvPr id="22" name="Text 17"/>
+          <p:cNvPr id="23" name="Text 18"/>
           <p:cNvSpPr/>
           <p:nvPr/>
         </p:nvSpPr>
@@ -13541,7 +13594,7 @@
       </p:sp>
       <p:sp>
         <p:nvSpPr>
-          <p:cNvPr id="23" name="Text 18"/>
+          <p:cNvPr id="24" name="Text 19"/>
           <p:cNvSpPr/>
           <p:nvPr/>
         </p:nvSpPr>
@@ -13580,7 +13633,7 @@
       </p:sp>
       <p:sp>
         <p:nvSpPr>
-          <p:cNvPr id="24" name="Text 19"/>
+          <p:cNvPr id="25" name="Text 20"/>
           <p:cNvSpPr/>
           <p:nvPr/>
         </p:nvSpPr>
@@ -13619,7 +13672,7 @@
       </p:sp>
       <p:sp>
         <p:nvSpPr>
-          <p:cNvPr id="25" name="Text 20"/>
+          <p:cNvPr id="26" name="Text 21"/>
           <p:cNvSpPr/>
           <p:nvPr/>
         </p:nvSpPr>
@@ -13658,7 +13711,7 @@
       </p:sp>
       <p:sp>
         <p:nvSpPr>
-          <p:cNvPr id="26" name="Text 21"/>
+          <p:cNvPr id="27" name="Text 22"/>
           <p:cNvSpPr/>
           <p:nvPr/>
         </p:nvSpPr>
@@ -13697,7 +13750,7 @@
       </p:sp>
       <p:sp>
         <p:nvSpPr>
-          <p:cNvPr id="27" name="Text 22"/>
+          <p:cNvPr id="28" name="Text 23"/>
           <p:cNvSpPr/>
           <p:nvPr/>
         </p:nvSpPr>
@@ -13736,7 +13789,7 @@
       </p:sp>
       <p:sp>
         <p:nvSpPr>
-          <p:cNvPr id="28" name="Text 23"/>
+          <p:cNvPr id="29" name="Text 24"/>
           <p:cNvSpPr/>
           <p:nvPr/>
         </p:nvSpPr>
@@ -13775,7 +13828,7 @@
       </p:sp>
       <p:sp>
         <p:nvSpPr>
-          <p:cNvPr id="29" name="Text 24"/>
+          <p:cNvPr id="30" name="Text 25"/>
           <p:cNvSpPr/>
           <p:nvPr/>
         </p:nvSpPr>
@@ -13814,7 +13867,7 @@
       </p:sp>
       <p:sp>
         <p:nvSpPr>
-          <p:cNvPr id="30" name="Text 25"/>
+          <p:cNvPr id="31" name="Text 26"/>
           <p:cNvSpPr/>
           <p:nvPr/>
         </p:nvSpPr>

</xml_diff>